<commit_message>
Update Lec 0 & 1 slides
</commit_message>
<xml_diff>
--- a/Slides/Lec0 - Introduction.pptx
+++ b/Slides/Lec0 - Introduction.pptx
@@ -305,7 +305,7 @@
       </p15:notesGuideLst>
     </p:ext>
     <p:ext uri="GoogleSlidesCustomDataVersion2">
-      <go:slidesCustomData xmlns:go="http://customooxmlschemas.google.com/" xmlns:ahyp="http://schemas.microsoft.com/office/drawing/2018/hyperlinkcolor" xmlns:p15="http://schemas.microsoft.com/office/powerpoint/2012/main" xmlns:p14="http://schemas.microsoft.com/office/powerpoint/2010/main" xmlns:com="http://schemas.openxmlformats.org/drawingml/2006/compatibility" xmlns:pvml="urn:schemas-microsoft-com:office:powerpoint" xmlns:v="urn:schemas-microsoft-com:vml" xmlns:o="urn:schemas-microsoft-com:office:office" xmlns:dgm="http://schemas.openxmlformats.org/drawingml/2006/diagram" xmlns:c="http://schemas.openxmlformats.org/drawingml/2006/chart" xmlns:mv="urn:schemas-microsoft-com:mac:vml" xmlns:mc="http://schemas.openxmlformats.org/markup-compatibility/2006" xmlns="" r:id="rId85" roundtripDataSignature="AMtx7mjnchW9jt+BL3pINn0mejfXPXn+WA=="/>
+      <go:slidesCustomData xmlns="" xmlns:mc="http://schemas.openxmlformats.org/markup-compatibility/2006" xmlns:mv="urn:schemas-microsoft-com:mac:vml" xmlns:c="http://schemas.openxmlformats.org/drawingml/2006/chart" xmlns:dgm="http://schemas.openxmlformats.org/drawingml/2006/diagram" xmlns:o="urn:schemas-microsoft-com:office:office" xmlns:v="urn:schemas-microsoft-com:vml" xmlns:pvml="urn:schemas-microsoft-com:office:powerpoint" xmlns:com="http://schemas.openxmlformats.org/drawingml/2006/compatibility" xmlns:p14="http://schemas.microsoft.com/office/powerpoint/2010/main" xmlns:p15="http://schemas.microsoft.com/office/powerpoint/2012/main" xmlns:ahyp="http://schemas.microsoft.com/office/drawing/2018/hyperlinkcolor" xmlns:go="http://customooxmlschemas.google.com/" r:id="rId85" roundtripDataSignature="AMtx7mjnchW9jt+BL3pINn0mejfXPXn+WA=="/>
     </p:ext>
   </p:extLst>
 </p:presentation>
@@ -405,7 +405,7 @@
           <a:p>
             <a:fld id="{C5083AF9-D621-4D22-98A6-93B8FF1F7E4E}" type="datetimeFigureOut">
               <a:rPr lang="en-US" smtClean="0"/>
-              <a:t>3/2/2026</a:t>
+              <a:t>3/11/2026</a:t>
             </a:fld>
             <a:endParaRPr lang="en-US"/>
           </a:p>

</xml_diff>